<commit_message>
Confidence intervals and stratified weighting for validation numbers (accuracy_ci.py, Olofsson/Stehman-style); slide 5 and script show CIs; ARCHITECTURE appendix 18
Co-Authored-By: Claude Opus 5.5 <noreply@anthropic.com>
</commit_message>
<xml_diff>
--- a/presentation/TASTI_SatDashboard-決賽簡報.pptx
+++ b/presentation/TASTI_SatDashboard-決賽簡報.pptx
@@ -112,24 +112,24 @@
   <p:extLst>
     <p:ext uri="{521415D9-36F7-43E2-AB2F-B90AF26B5E84}">
       <p14:sectionLst xmlns:p14="http://schemas.microsoft.com/office/powerpoint/2010/main">
-        <p14:section name="開場" id="{fbdae2e5-bc5c-f318-0149-4ef21d0e667e}">
+        <p14:section name="開場" id="{3f5096d1-6bee-6b12-8b3f-cc3258ae7e16}">
           <p14:sldIdLst>
             <p14:sldId id="256"/>
           </p14:sldIdLst>
         </p14:section>
-        <p14:section name="問題與方法" id="{9799581d-4673-1da2-d796-3c4e3bf2fcab}">
+        <p14:section name="問題與方法" id="{19af9d17-ec7f-8994-7ea7-00495ee6a29a}">
           <p14:sldIdLst>
             <p14:sldId id="257"/>
             <p14:sldId id="258"/>
           </p14:sldIdLst>
         </p14:section>
-        <p14:section name="成果與驗證" id="{b28da743-6496-c6f2-05b7-c0a8b12fa01e}">
+        <p14:section name="成果與驗證" id="{9b563ea4-ea1b-0285-e91a-410005b857b8}">
           <p14:sldIdLst>
             <p14:sldId id="259"/>
             <p14:sldId id="260"/>
           </p14:sldIdLst>
         </p14:section>
-        <p14:section name="落地" id="{74d85097-df9d-3649-62a8-1468db033f2c}">
+        <p14:section name="落地" id="{5340f6f6-1557-1d98-cb5c-8851e28fa9e2}">
           <p14:sldIdLst>
             <p14:sldId id="261"/>
           </p14:sldIdLst>
@@ -1834,7 +1834,7 @@
           <a:p>
             <a:r>
               <a:rPr lang="en-US" dirty="0"/>
-              <a:t>我們不只做系統，也量了它準不準。影像目視與官方圖層的有無裸露一致率只有 69%；舊版近期變化訊號約四分之一屬實。我們參考水保署電子報改用紅邊指標。在高雄全區，零星的下降經盲判只有 5/26 屬實；但在大事件後，花蓮有 75%、太魯閣有 43% 的崩塌坡面被抓到，沒有事件的坡面誤報約 2%。左邊這張圖是太魯閣：崩塌占坡面不到 5% 時只抓到 7%，超過四成時抓到 93%。所以紅邊指標適合大事件後快速找出植被大片消失的坡面，自動訊號只用來排出先看誰，最後一定由人確認。（約 55 秒）</a:t>
+              <a:t>我們不只做系統，也量了它準不準。影像目視與官方圖層的有無裸露一致率只有 69%；舊版近期變化訊號約四分之一屬實。我們參考水保署電子報改用紅邊指標。在高雄全區，零星的下降經分層盲判只有約 25% 屬實，信賴區間 5% 到 45%；但在大事件後，花蓮有 75%、太魯閣有 43% 的崩塌坡面被抓到，沒有事件的坡面誤報約 2%。左邊這張圖是太魯閣：崩塌占坡面不到 5% 時只抓到 7%，超過四成時抓到 93%。所以紅邊指標適合大事件後快速找出植被大片消失的坡面，自動訊號只用來排出先看誰，最後一定由人確認。（約 55 秒）</a:t>
             </a:r>
             <a:endParaRPr lang="en-US" dirty="0"/>
           </a:p>
@@ -5308,7 +5308,7 @@
                   <a:schemeClr val="accent4"/>
                 </a:solidFill>
               </a:rPr>
-              <a:t>人工盲測 n=29</a:t>
+              <a:t>人工盲測 n=29；95% CI 51–83%</a:t>
             </a:r>
             <a:endParaRPr lang="en-US" sz="1100" dirty="0"/>
           </a:p>
@@ -5443,7 +5443,7 @@
                   <a:schemeClr val="accent4"/>
                 </a:solidFill>
               </a:rPr>
-              <a:t>24 個分層坡面</a:t>
+              <a:t>分層驗證 S1 層 n=4；95% CI 5–70%</a:t>
             </a:r>
             <a:endParaRPr lang="en-US" sz="1100" dirty="0"/>
           </a:p>
@@ -5506,7 +5506,7 @@
                   <a:schemeClr val="accent2"/>
                 </a:solidFill>
               </a:rPr>
-              <a:t>5/26</a:t>
+              <a:t>約 25%</a:t>
             </a:r>
             <a:endParaRPr lang="en-US" sz="2800" dirty="0"/>
           </a:p>
@@ -5578,7 +5578,7 @@
                   <a:schemeClr val="accent4"/>
                 </a:solidFill>
               </a:rPr>
-              <a:t>32 個坡面分層盲判</a:t>
+              <a:t>分層加權（5/26）；95% CI 5–45%</a:t>
             </a:r>
             <a:endParaRPr lang="en-US" sz="1100" dirty="0"/>
           </a:p>
@@ -5713,7 +5713,7 @@
                   <a:schemeClr val="accent4"/>
                 </a:solidFill>
               </a:rPr>
-              <a:t>事件目錄對照，崩塌占坡面兩成以上才可靠</a:t>
+              <a:t>95% CI 66–83%・38–48%；誤報 1.9%・2.0%</a:t>
             </a:r>
             <a:endParaRPr lang="en-US" sz="1100" dirty="0"/>
           </a:p>

</xml_diff>

<commit_message>
New landing page (five themes), debris-flow links and reference overlays on /su, 5 new UAV registrations
- /: concise landing for the finals (technical highlights, architecture, resilience, lessons for government and the public); former home moved to /system
- su_debris_link.py: per-slope debris-flow potential stream watershed, affected area within 100 m and nearest stream (ARDSWC BigGIS vector tiles snapshot); /su block 5, tiers unchanged
- /su map: NLSC yearly orthophotos 2014-2025, GSMMA dip-slope / historical landslide / geologically sensitive area tiles, NLSC lidar terrain change (reference only)
- UAV: 5 new registrations from 2026-09/10 uploads (3 at Liugui Baolai), total 35; uav_synth.find_rec reads uav_cands_2026c.json
- /roadmap module 5 now partial; deck slide 7, script, ARCHITECTURE appendix 20

Co-Authored-By: Claude Opus 5.5 <noreply@anthropic.com>
</commit_message>
<xml_diff>
--- a/presentation/TASTI_SatDashboard-決賽簡報.pptx
+++ b/presentation/TASTI_SatDashboard-決賽簡報.pptx
@@ -114,29 +114,29 @@
   <p:extLst>
     <p:ext uri="{521415D9-36F7-43E2-AB2F-B90AF26B5E84}">
       <p14:sectionLst xmlns:p14="http://schemas.microsoft.com/office/powerpoint/2010/main">
-        <p14:section name="開場" id="{3b007b5c-3dc5-8d03-bf21-32d7d37d0834}">
+        <p14:section name="開場" id="{d3ab1438-0ed6-f0dc-05e1-134f9eac79a9}">
           <p14:sldIdLst>
             <p14:sldId id="256"/>
           </p14:sldIdLst>
         </p14:section>
-        <p14:section name="問題與方法" id="{6a8ca646-5483-ddc6-1ebd-e0ca97124c67}">
+        <p14:section name="問題與方法" id="{1c92431d-8955-8ef7-9f58-4a20641f9c35}">
           <p14:sldIdLst>
             <p14:sldId id="257"/>
             <p14:sldId id="258"/>
           </p14:sldIdLst>
         </p14:section>
-        <p14:section name="成果與驗證" id="{16ed2de3-4792-cccb-29ff-5dbb7088d0fc}">
+        <p14:section name="成果與驗證" id="{ca2b576e-e524-c3bd-9719-5a649d21af4c}">
           <p14:sldIdLst>
             <p14:sldId id="259"/>
             <p14:sldId id="260"/>
           </p14:sldIdLst>
         </p14:section>
-        <p14:section name="落地" id="{65173dfe-13bf-67d3-8a1c-42b30702e95e}">
+        <p14:section name="落地" id="{e1707dac-232d-d61b-e989-cc35e71c0a95}">
           <p14:sldIdLst>
             <p14:sldId id="261"/>
           </p14:sldIdLst>
         </p14:section>
-        <p14:section name="備用" id="{a7aa1d1a-fa10-ee07-bebe-103f6fe6690a}">
+        <p14:section name="備用" id="{89eeb5e3-7a74-a3c4-b07b-bb437b600e2a}">
           <p14:sldIdLst>
             <p14:sldId id="262"/>
             <p14:sldId id="263"/>
@@ -2018,7 +2018,7 @@
           <a:p>
             <a:r>
               <a:rPr lang="en-US" dirty="0"/>
-              <a:t>（備用，評審問到系統藍圖或下一步時再翻。）專家提出的崩塌智慧防災平台有六個模組。我們目前做到的是平時篩查：坡地底圖、多源監測和 AI 輔助判釋都有一部分，其中道路與建物暴露是用 OpenStreetMap 疊合，回答坡面崩了會碰到什麼，但不改候選層級。地質目前只拿到影像圖磚，五萬分之一的斷層、位態、順向坡要取得向量後才能分析。降雨觸發、下游災害鏈和應變工作流還沒做，這是從平時篩查走向事件反應的下一步。</a:t>
+              <a:t>（備用，評審問到系統藍圖或下一步時再翻。）專家提出的崩塌智慧防災平台有六個模組。我們目前做到的是平時篩查：坡地底圖、多源監測和 AI 輔助判釋都有一部分，其中道路與建物暴露是用 OpenStreetMap 疊合，回答坡面崩了會碰到什麼，但不改候選層級。地質目前只拿到影像圖磚，五萬分之一的斷層、位態、順向坡要取得向量後才能分析。下游影響目前只列出坡面所在的土石流潛勢溪流集水區與影響範圍；降雨觸發、土砂與河道的動態串接和應變工作流還沒做，這是從平時篩查走向事件反應的下一步。</a:t>
             </a:r>
             <a:endParaRPr lang="en-US" dirty="0"/>
           </a:p>
@@ -7473,11 +7473,11 @@
             </a:avLst>
           </a:prstGeom>
           <a:solidFill>
-            <a:schemeClr val="accent4"/>
+            <a:schemeClr val="accent1"/>
           </a:solidFill>
           <a:ln w="12700">
             <a:solidFill>
-              <a:schemeClr val="accent4"/>
+              <a:schemeClr val="accent1"/>
             </a:solidFill>
             <a:prstDash val="solid"/>
           </a:ln>
@@ -7513,7 +7513,7 @@
                   <a:schemeClr val="bg1"/>
                 </a:solidFill>
               </a:rPr>
-              <a:t>未做</a:t>
+              <a:t>部分</a:t>
             </a:r>
             <a:endParaRPr lang="en-US" sz="1200" dirty="0"/>
           </a:p>
@@ -7566,7 +7566,7 @@
                   <a:schemeClr val="tx1"/>
                 </a:solidFill>
               </a:rPr>
-              <a:t>花蓮堰塞湖只做到崩塌偵測</a:t>
+              <a:t>坡面所在的土石流潛勢溪流集水區與影響範圍（水保署）</a:t>
             </a:r>
             <a:endParaRPr lang="en-US" sz="1400" dirty="0"/>
           </a:p>
@@ -7597,7 +7597,7 @@
                   <a:schemeClr val="accent4"/>
                 </a:solidFill>
               </a:rPr>
-              <a:t>崩塌 → 土砂 → 河道 → 堰塞 → 下游的串接</a:t>
+              <a:t>土砂量、河道、堰塞、下游的動態串接</a:t>
             </a:r>
             <a:endParaRPr lang="en-US" sz="1400" dirty="0"/>
           </a:p>

</xml_diff>